<commit_message>
Remove the v6 benchmark report (report_v6/) + root summary duplicate
Drops the committed v6 report per request: report_v6/ (RESULTS.md, FORMAT.md,
SUMMARY.md/.txt, figures/) and the root SUMMARY_v6.txt (a verbatim duplicate of
report_v6/SUMMARY.txt).

Repoint the generators off the deleted dir so a re-run doesn't recreate it, and
fix the dangling references:
- plot_pareto.py: default OUT_DIR report_v6/figures -> figures/
- make_slides.py: point the "full numbers" text at results/final/ +
  summarize_final.py / plot_pareto.py; pareto embed -> figures/pareto.png
  (skipped when absent); regenerate the deck (drops the embedded v6 pareto chart)
- README.md, report_pass2/README.md: drop links to the removed report_v6/

The v6 numbers stay reproducible from results/final/ via summarize_final.py +
plot_pareto.py, and remain in git history.

Co-Authored-By: Claude Opus 4.8 (1M context) <noreply@anthropic.com>
Claude-Session: https://claude.ai/code/session_01HKupsjEMZA8sZXab8RsbSD
</commit_message>
<xml_diff>
--- a/slides/benchmark_overview.pptx
+++ b/slides/benchmark_overview.pptx
@@ -5722,7 +5722,7 @@
                 </a:solidFill>
                 <a:latin typeface="Calibri"/>
               </a:rPr>
-              <a:t>file stats: scripts/dataset_stats.py (tokens ≈ chars/4) · served ISL/OSL: aiperf, report_v6</a:t>
+              <a:t>file stats: scripts/dataset_stats.py (tokens ≈ chars/4) · served ISL/OSL: aiperf</a:t>
             </a:r>
           </a:p>
         </p:txBody>
@@ -8150,7 +8150,7 @@
                 </a:solidFill>
                 <a:latin typeface="Calibri"/>
               </a:rPr>
-              <a:t>full tables: report_v6/SUMMARY.md · figures: report_v6/figures/</a:t>
+              <a:t>tables + figures: scripts/summarize_final.py · scripts/plot_pareto.py (from results/final/)</a:t>
             </a:r>
           </a:p>
         </p:txBody>
@@ -8326,72 +8326,6 @@
                 <a:latin typeface="Calibri"/>
               </a:rPr>
               <a:t>Big batch budget pays: max-num-batched-tokens 248,320 lets 16 rag prefills batch in one step — TTFT −35 %, req/s +24 % (vs default budget; GPU util 0.5→0.85 changed with it)</a:t>
-            </a:r>
-          </a:p>
-        </p:txBody>
-      </p:sp>
-      <p:pic>
-        <p:nvPicPr>
-          <p:cNvPr id="6" name="Picture 5" descr="pareto.png"/>
-          <p:cNvPicPr>
-            <a:picLocks noChangeAspect="1"/>
-          </p:cNvPicPr>
-          <p:nvPr/>
-        </p:nvPicPr>
-        <p:blipFill>
-          <a:blip r:embed="rId2"/>
-          <a:stretch>
-            <a:fillRect/>
-          </a:stretch>
-        </p:blipFill>
-        <p:spPr>
-          <a:xfrm>
-            <a:off x="6537960" y="1417320"/>
-            <a:ext cx="5394960" cy="2157984"/>
-          </a:xfrm>
-          <a:prstGeom prst="rect">
-            <a:avLst/>
-          </a:prstGeom>
-        </p:spPr>
-      </p:pic>
-      <p:sp>
-        <p:nvSpPr>
-          <p:cNvPr id="7" name="TextBox 6"/>
-          <p:cNvSpPr txBox="1"/>
-          <p:nvPr/>
-        </p:nvSpPr>
-        <p:spPr>
-          <a:xfrm>
-            <a:off x="6537960" y="5989320"/>
-            <a:ext cx="5394960" cy="365760"/>
-          </a:xfrm>
-          <a:prstGeom prst="rect">
-            <a:avLst/>
-          </a:prstGeom>
-          <a:noFill/>
-        </p:spPr>
-        <p:txBody>
-          <a:bodyPr wrap="square" anchor="t">
-            <a:spAutoFit/>
-          </a:bodyPr>
-          <a:lstStyle/>
-          <a:p>
-            <a:pPr algn="ctr">
-              <a:lnSpc>
-                <a:spcPct val="100000"/>
-              </a:lnSpc>
-              <a:spcAft>
-                <a:spcPts val="200"/>
-              </a:spcAft>
-            </a:pPr>
-            <a:r>
-              <a:rPr sz="1000" b="0">
-                <a:solidFill>
-                  <a:srgbClr val="5A6670"/>
-                </a:solidFill>
-                <a:latin typeface="Calibri"/>
-              </a:rPr>
-              <a:t>Throughput vs per-user interactivity (Pareto), per workload &amp; concurrency</a:t>
             </a:r>
           </a:p>
         </p:txBody>
@@ -8741,7 +8675,7 @@
                           </a:solidFill>
                           <a:latin typeface="Calibri"/>
                         </a:rPr>
-                        <a:t>report_v6/ (SUMMARY.md, RESULTS.md, figures/) · earlier passes in RESULTS.md</a:t>
+                        <a:t>results/final/ → summarize_final.py + plot_pareto.py · earlier passes in RESULTS.md</a:t>
                       </a:r>
                     </a:p>
                   </a:txBody>

</xml_diff>